<commit_message>
Scale up all income stream slides - bigger text and visuals
All 5 slides proportionately increased:
- Titles: +8px across all slides
- Stream labels: 18→20px
- Subtitles: 18→20px
- Feature percentages: 36→40px
- Feature names: 15→17px
- Feature descriptions: 14→16px
- Earning values: 40→44px
- Earning labels: 14→16px
- Referral nodes: 52→58px circles, icons 26→30px
- YOU circle: 76→84px
- Nexus cells: 48→54px, L3 cells: 26→30px
- Course cards: 320→360px, thumbnails 50→56px
- Grid: 340→370px, Globe: 380→400px
- All right-side visuals scaled proportionately

20 language versions regenerated.
</commit_message>
<xml_diff>
--- a/static/downloads/income-streams/SuperAdPro-4-Income-Streams-AR.pptx
+++ b/static/downloads/income-streams/SuperAdPro-4-Income-Streams-AR.pptx
@@ -506,7 +506,7 @@
           <a:p>
             <a:r>
               <a:rPr lang="en-US" dirty="0"/>
-              <a:t>4 Income Streams - SuperAdPro (العربية)</a:t>
+              <a:t>4 Income Streams - العربية</a:t>
             </a:r>
             <a:endParaRPr lang="en-US" dirty="0"/>
           </a:p>
@@ -594,7 +594,7 @@
           <a:p>
             <a:r>
               <a:rPr lang="en-US" dirty="0"/>
-              <a:t>Membership Referrals - SuperAdPro (العربية)</a:t>
+              <a:t>Membership Referrals - العربية</a:t>
             </a:r>
             <a:endParaRPr lang="en-US" dirty="0"/>
           </a:p>
@@ -682,7 +682,7 @@
           <a:p>
             <a:r>
               <a:rPr lang="en-US" dirty="0"/>
-              <a:t>Campaign Grid - SuperAdPro (العربية)</a:t>
+              <a:t>Campaign Grid - العربية</a:t>
             </a:r>
             <a:endParaRPr lang="en-US" dirty="0"/>
           </a:p>
@@ -770,7 +770,7 @@
           <a:p>
             <a:r>
               <a:rPr lang="en-US" dirty="0"/>
-              <a:t>Credit Nexus - SuperAdPro (العربية)</a:t>
+              <a:t>Credit Nexus - العربية</a:t>
             </a:r>
             <a:endParaRPr lang="en-US" dirty="0"/>
           </a:p>
@@ -858,7 +858,7 @@
           <a:p>
             <a:r>
               <a:rPr lang="en-US" dirty="0"/>
-              <a:t>Course Academy - SuperAdPro (العربية)</a:t>
+              <a:t>Course Academy - العربية</a:t>
             </a:r>
             <a:endParaRPr lang="en-US" dirty="0"/>
           </a:p>

</xml_diff>